<commit_message>
Add live Streamlit demo link to README and closing slide
</commit_message>
<xml_diff>
--- a/docs/Antaral_BetweenBeats_presentation.pptx
+++ b/docs/Antaral_BetweenBeats_presentation.pptx
@@ -4401,6 +4401,26 @@
               <a:buNone/>
             </a:pPr>
             <a:r>
+              <a:rPr lang="en-US" sz="1500" dirty="0">
+                <a:solidFill>
+                  <a:srgbClr val="B8D4D0"/>
+                </a:solidFill>
+                <a:latin typeface="Calibri" pitchFamily="34" charset="0"/>
+                <a:ea typeface="Calibri" pitchFamily="34" charset="-122"/>
+                <a:cs typeface="Calibri" pitchFamily="34" charset="-120"/>
+              </a:rPr>
+              <a:t>Live demo: betweenbeatsvit-bhopal-university-cmf2hewrxvj5wfdtksbfho.streamlit.app</a:t>
+            </a:r>
+            <a:endParaRPr lang="en-US" sz="1500" dirty="0"/>
+          </a:p>
+          <a:p>
+            <a:pPr indent="0" marL="0">
+              <a:spcAft>
+                <a:spcPts val="400"/>
+              </a:spcAft>
+              <a:buNone/>
+            </a:pPr>
+            <a:r>
               <a:rPr lang="en-US" sz="1200" dirty="0">
                 <a:solidFill>
                   <a:srgbClr val="8FB0AC"/>

</xml_diff>